<commit_message>
Slides nuova versione. WIP 2
</commit_message>
<xml_diff>
--- a/06_relazioni_e_parametri/Slides_v2/02b_simulazione-quantistica.pptx
+++ b/06_relazioni_e_parametri/Slides_v2/02b_simulazione-quantistica.pptx
@@ -976,8 +976,8 @@
           </a:p>
         </p:txBody>
       </p:sp>
-      <mc:AlternateContent xmlns:mc="http://schemas.openxmlformats.org/markup-compatibility/2006">
-        <mc:Choice xmlns:a14="http://schemas.microsoft.com/office/drawing/2010/main" Requires="a14">
+      <mc:AlternateContent xmlns:mc="http://schemas.openxmlformats.org/markup-compatibility/2006" xmlns:a14="http://schemas.microsoft.com/office/drawing/2010/main">
+        <mc:Choice Requires="a14">
           <p:sp>
             <p:nvSpPr>
               <p:cNvPr id="10" name="Text 8"/>
@@ -1211,7 +1211,7 @@
             </p:txBody>
           </p:sp>
         </mc:Choice>
-        <mc:Fallback>
+        <mc:Fallback xmlns="">
           <p:sp>
             <p:nvSpPr>
               <p:cNvPr id="10" name="Text 8"/>
@@ -1974,486 +1974,147 @@
           </a:p>
         </p:txBody>
       </p:sp>
-      <mc:AlternateContent xmlns:mc="http://schemas.openxmlformats.org/markup-compatibility/2006">
-        <mc:Choice xmlns:a14="http://schemas.microsoft.com/office/drawing/2010/main" Requires="a14">
-          <p:sp>
-            <p:nvSpPr>
-              <p:cNvPr id="15" name="TextBox 14">
-                <a:extLst>
-                  <a:ext uri="{FF2B5EF4-FFF2-40B4-BE49-F238E27FC236}">
-                    <a16:creationId xmlns:a16="http://schemas.microsoft.com/office/drawing/2014/main" id="{3F81D78E-2635-CA71-64D6-1587924DA2D3}"/>
-                  </a:ext>
-                </a:extLst>
-              </p:cNvPr>
-              <p:cNvSpPr txBox="1"/>
-              <p:nvPr/>
-            </p:nvSpPr>
-            <p:spPr>
-              <a:xfrm>
-                <a:off x="5959364" y="5150571"/>
-                <a:ext cx="5592247" cy="1578445"/>
-              </a:xfrm>
-              <a:prstGeom prst="rect">
-                <a:avLst/>
-              </a:prstGeom>
-              <a:noFill/>
-            </p:spPr>
-            <p:txBody>
-              <a:bodyPr wrap="square" rtlCol="0">
-                <a:spAutoFit/>
-              </a:bodyPr>
-              <a:lstStyle/>
-              <a:p>
-                <a:r>
-                  <a:rPr lang="en-US" sz="1600" dirty="0"/>
-                  <a:t>Determinazione </a:t>
-                </a:r>
-                <a:r>
-                  <a:rPr lang="en-US" sz="1600" dirty="0" err="1"/>
-                  <a:t>dello</a:t>
-                </a:r>
-                <a:r>
-                  <a:rPr lang="en-US" sz="1600" dirty="0"/>
-                  <a:t> </a:t>
-                </a:r>
-                <a:r>
-                  <a:rPr lang="en-US" sz="1600" b="1" dirty="0" err="1"/>
-                  <a:t>stato</a:t>
-                </a:r>
-                <a:r>
-                  <a:rPr lang="en-US" sz="1600" b="1" dirty="0"/>
-                  <a:t> </a:t>
-                </a:r>
-                <a:r>
-                  <a:rPr lang="en-US" sz="1600" b="1" dirty="0" err="1"/>
-                  <a:t>fondamentale</a:t>
-                </a:r>
-                <a:r>
-                  <a:rPr lang="en-US" sz="1600" dirty="0"/>
-                  <a:t> per lo studio </a:t>
-                </a:r>
-                <a:r>
-                  <a:rPr lang="en-US" sz="1600" dirty="0" err="1"/>
-                  <a:t>statico</a:t>
-                </a:r>
-                <a:r>
-                  <a:rPr lang="en-US" sz="1600" dirty="0"/>
-                  <a:t> del </a:t>
-                </a:r>
-                <a:r>
-                  <a:rPr lang="en-US" sz="1600" dirty="0" err="1"/>
-                  <a:t>sistema</a:t>
-                </a:r>
-                <a:r>
-                  <a:rPr lang="en-US" sz="1600" dirty="0"/>
-                  <a:t>, e </a:t>
-                </a:r>
-                <a:r>
-                  <a:rPr lang="en-US" sz="1600" dirty="0" err="1"/>
-                  <a:t>simulazione</a:t>
-                </a:r>
-                <a:r>
-                  <a:rPr lang="en-US" sz="1600" dirty="0"/>
-                  <a:t> delle </a:t>
-                </a:r>
-                <a:r>
-                  <a:rPr lang="en-US" sz="1600" dirty="0" err="1"/>
-                  <a:t>proprietà</a:t>
-                </a:r>
-                <a:r>
-                  <a:rPr lang="en-US" sz="1600" dirty="0"/>
-                  <a:t> </a:t>
-                </a:r>
-                <a:r>
-                  <a:rPr lang="en-US" sz="1600" dirty="0" err="1"/>
-                  <a:t>dinamiche</a:t>
-                </a:r>
-                <a:r>
-                  <a:rPr lang="en-US" sz="1600" dirty="0"/>
-                  <a:t> come </a:t>
-                </a:r>
-                <a:r>
-                  <a:rPr lang="en-US" sz="1600" b="1" dirty="0" err="1"/>
-                  <a:t>evoluzione</a:t>
-                </a:r>
-                <a:r>
-                  <a:rPr lang="en-US" sz="1600" b="1" dirty="0"/>
-                  <a:t> </a:t>
-                </a:r>
-                <a:r>
-                  <a:rPr lang="en-US" sz="1600" b="1" dirty="0" err="1"/>
-                  <a:t>temporale</a:t>
-                </a:r>
-                <a:r>
-                  <a:rPr lang="en-US" sz="1600" b="1" dirty="0"/>
-                  <a:t> </a:t>
-                </a:r>
-                <a:r>
-                  <a:rPr lang="en-US" sz="1600" dirty="0" err="1"/>
-                  <a:t>approssimata</a:t>
-                </a:r>
-                <a:r>
-                  <a:rPr lang="en-US" sz="1600" dirty="0"/>
-                  <a:t> con la </a:t>
-                </a:r>
-                <a:r>
-                  <a:rPr lang="en-US" sz="1600" dirty="0" err="1"/>
-                  <a:t>decomposizione</a:t>
-                </a:r>
-                <a:r>
-                  <a:rPr lang="en-US" sz="1600" dirty="0"/>
-                  <a:t> di </a:t>
-                </a:r>
-                <a:r>
-                  <a:rPr lang="en-US" sz="1600" b="1" dirty="0"/>
-                  <a:t>Suzuki–Trotter</a:t>
-                </a:r>
-                <a:r>
-                  <a:rPr lang="en-US" sz="1400" dirty="0"/>
-                  <a:t>:</a:t>
-                </a:r>
-                <a:br>
-                  <a:rPr lang="en-US" sz="1400" dirty="0"/>
-                </a:br>
-                <a:endParaRPr lang="en-US" sz="1400" dirty="0"/>
-              </a:p>
-              <a:p>
-                <a:pPr/>
-                <a14:m>
-                  <m:oMathPara xmlns:m="http://schemas.openxmlformats.org/officeDocument/2006/math">
-                    <m:oMath>
-                      <m:r>
-                        <a:rPr lang="en-US" sz="1400" i="1">
-                          <a:latin typeface="Cambria Math" panose="02040503050406030204" pitchFamily="18" charset="0"/>
-                        </a:rPr>
-                        <m:t>𝑈</m:t>
-                      </m:r>
-                      <m:d>
-                        <m:dPr>
-                          <m:ctrlPr>
-                            <a:rPr lang="en-US" sz="1400" i="1">
-                              <a:latin typeface="Cambria Math" panose="02040503050406030204" pitchFamily="18" charset="0"/>
-                            </a:rPr>
-                          </m:ctrlPr>
-                        </m:dPr>
-                        <m:e>
-                          <m:r>
-                            <a:rPr lang="en-US" sz="1400" i="1">
-                              <a:latin typeface="Cambria Math" panose="02040503050406030204" pitchFamily="18" charset="0"/>
-                            </a:rPr>
-                            <m:t>𝑡</m:t>
-                          </m:r>
-                        </m:e>
-                      </m:d>
-                      <m:r>
-                        <a:rPr lang="en-US" sz="1400" b="0" i="1" smtClean="0">
-                          <a:latin typeface="Cambria Math" panose="02040503050406030204" pitchFamily="18" charset="0"/>
-                        </a:rPr>
-                        <m:t>=</m:t>
-                      </m:r>
-                      <m:sSup>
-                        <m:sSupPr>
-                          <m:ctrlPr>
-                            <a:rPr lang="en-US" sz="1400" i="1">
-                              <a:latin typeface="Cambria Math" panose="02040503050406030204" pitchFamily="18" charset="0"/>
-                            </a:rPr>
-                          </m:ctrlPr>
-                        </m:sSupPr>
-                        <m:e>
-                          <m:r>
-                            <a:rPr lang="en-US" sz="1400" i="1">
-                              <a:latin typeface="Cambria Math" panose="02040503050406030204" pitchFamily="18" charset="0"/>
-                            </a:rPr>
-                            <m:t>𝑒</m:t>
-                          </m:r>
-                        </m:e>
-                        <m:sup>
-                          <m:r>
-                            <a:rPr lang="en-US" sz="1400">
-                              <a:latin typeface="Cambria Math" panose="02040503050406030204" pitchFamily="18" charset="0"/>
-                            </a:rPr>
-                            <m:t>−</m:t>
-                          </m:r>
-                          <m:r>
-                            <a:rPr lang="en-US" sz="1400" i="1">
-                              <a:latin typeface="Cambria Math" panose="02040503050406030204" pitchFamily="18" charset="0"/>
-                            </a:rPr>
-                            <m:t>𝑖𝐻</m:t>
-                          </m:r>
-                          <m:r>
-                            <m:rPr>
-                              <m:sty m:val="p"/>
-                            </m:rPr>
-                            <a:rPr lang="en-US" sz="1400" b="0" i="1" smtClean="0">
-                              <a:latin typeface="Cambria Math" panose="02040503050406030204" pitchFamily="18" charset="0"/>
-                            </a:rPr>
-                            <m:t>t</m:t>
-                          </m:r>
-                        </m:sup>
-                      </m:sSup>
-                      <m:r>
-                        <a:rPr lang="en-US" sz="1400">
-                          <a:latin typeface="Cambria Math" panose="02040503050406030204" pitchFamily="18" charset="0"/>
-                        </a:rPr>
-                        <m:t>≈</m:t>
-                      </m:r>
-                      <m:sSup>
-                        <m:sSupPr>
-                          <m:ctrlPr>
-                            <a:rPr lang="en-US" sz="1400" i="1">
-                              <a:latin typeface="Cambria Math" panose="02040503050406030204" pitchFamily="18" charset="0"/>
-                            </a:rPr>
-                          </m:ctrlPr>
-                        </m:sSupPr>
-                        <m:e>
-                          <m:d>
-                            <m:dPr>
-                              <m:ctrlPr>
-                                <a:rPr lang="en-US" sz="1400" i="1">
-                                  <a:latin typeface="Cambria Math" panose="02040503050406030204" pitchFamily="18" charset="0"/>
-                                </a:rPr>
-                              </m:ctrlPr>
-                            </m:dPr>
-                            <m:e>
-                              <m:sSup>
-                                <m:sSupPr>
-                                  <m:ctrlPr>
-                                    <a:rPr lang="en-US" sz="1400" i="1">
-                                      <a:latin typeface="Cambria Math" panose="02040503050406030204" pitchFamily="18" charset="0"/>
-                                    </a:rPr>
-                                  </m:ctrlPr>
-                                </m:sSupPr>
-                                <m:e>
-                                  <m:r>
-                                    <a:rPr lang="en-US" sz="1400" i="1">
-                                      <a:latin typeface="Cambria Math" panose="02040503050406030204" pitchFamily="18" charset="0"/>
-                                    </a:rPr>
-                                    <m:t>𝑒</m:t>
-                                  </m:r>
-                                </m:e>
-                                <m:sup>
-                                  <m:r>
-                                    <a:rPr lang="en-US" sz="1400">
-                                      <a:latin typeface="Cambria Math" panose="02040503050406030204" pitchFamily="18" charset="0"/>
-                                    </a:rPr>
-                                    <m:t>−</m:t>
-                                  </m:r>
-                                  <m:r>
-                                    <a:rPr lang="en-US" sz="1400" i="1">
-                                      <a:latin typeface="Cambria Math" panose="02040503050406030204" pitchFamily="18" charset="0"/>
-                                    </a:rPr>
-                                    <m:t>𝑖</m:t>
-                                  </m:r>
-                                  <m:sSub>
-                                    <m:sSubPr>
-                                      <m:ctrlPr>
-                                        <a:rPr lang="en-US" sz="1400" i="1">
-                                          <a:latin typeface="Cambria Math" panose="02040503050406030204" pitchFamily="18" charset="0"/>
-                                        </a:rPr>
-                                      </m:ctrlPr>
-                                    </m:sSubPr>
-                                    <m:e>
-                                      <m:r>
-                                        <a:rPr lang="en-US" sz="1400" i="1">
-                                          <a:latin typeface="Cambria Math" panose="02040503050406030204" pitchFamily="18" charset="0"/>
-                                        </a:rPr>
-                                        <m:t>𝐻</m:t>
-                                      </m:r>
-                                    </m:e>
-                                    <m:sub>
-                                      <m:r>
-                                        <a:rPr lang="en-US" sz="1400">
-                                          <a:latin typeface="Cambria Math" panose="02040503050406030204" pitchFamily="18" charset="0"/>
-                                        </a:rPr>
-                                        <m:t>1</m:t>
-                                      </m:r>
-                                    </m:sub>
-                                  </m:sSub>
-                                  <m:r>
-                                    <a:rPr lang="en-US" sz="1400" i="1">
-                                      <a:latin typeface="Cambria Math" panose="02040503050406030204" pitchFamily="18" charset="0"/>
-                                    </a:rPr>
-                                    <m:t>𝜏</m:t>
-                                  </m:r>
-                                </m:sup>
-                              </m:sSup>
-                              <m:sSup>
-                                <m:sSupPr>
-                                  <m:ctrlPr>
-                                    <a:rPr lang="en-US" sz="1400" i="1">
-                                      <a:latin typeface="Cambria Math" panose="02040503050406030204" pitchFamily="18" charset="0"/>
-                                    </a:rPr>
-                                  </m:ctrlPr>
-                                </m:sSupPr>
-                                <m:e>
-                                  <m:r>
-                                    <a:rPr lang="en-US" sz="1400" i="1">
-                                      <a:latin typeface="Cambria Math" panose="02040503050406030204" pitchFamily="18" charset="0"/>
-                                    </a:rPr>
-                                    <m:t>𝑒</m:t>
-                                  </m:r>
-                                </m:e>
-                                <m:sup>
-                                  <m:r>
-                                    <a:rPr lang="en-US" sz="1400">
-                                      <a:latin typeface="Cambria Math" panose="02040503050406030204" pitchFamily="18" charset="0"/>
-                                    </a:rPr>
-                                    <m:t>−</m:t>
-                                  </m:r>
-                                  <m:r>
-                                    <a:rPr lang="en-US" sz="1400" i="1">
-                                      <a:latin typeface="Cambria Math" panose="02040503050406030204" pitchFamily="18" charset="0"/>
-                                    </a:rPr>
-                                    <m:t>𝑖</m:t>
-                                  </m:r>
-                                  <m:sSub>
-                                    <m:sSubPr>
-                                      <m:ctrlPr>
-                                        <a:rPr lang="en-US" sz="1400" i="1">
-                                          <a:latin typeface="Cambria Math" panose="02040503050406030204" pitchFamily="18" charset="0"/>
-                                        </a:rPr>
-                                      </m:ctrlPr>
-                                    </m:sSubPr>
-                                    <m:e>
-                                      <m:r>
-                                        <a:rPr lang="en-US" sz="1400" i="1">
-                                          <a:latin typeface="Cambria Math" panose="02040503050406030204" pitchFamily="18" charset="0"/>
-                                        </a:rPr>
-                                        <m:t>𝐻</m:t>
-                                      </m:r>
-                                    </m:e>
-                                    <m:sub>
-                                      <m:r>
-                                        <a:rPr lang="en-US" sz="1400">
-                                          <a:latin typeface="Cambria Math" panose="02040503050406030204" pitchFamily="18" charset="0"/>
-                                        </a:rPr>
-                                        <m:t>2</m:t>
-                                      </m:r>
-                                    </m:sub>
-                                  </m:sSub>
-                                  <m:r>
-                                    <a:rPr lang="en-US" sz="1400" i="1">
-                                      <a:latin typeface="Cambria Math" panose="02040503050406030204" pitchFamily="18" charset="0"/>
-                                    </a:rPr>
-                                    <m:t>𝜏</m:t>
-                                  </m:r>
-                                </m:sup>
-                              </m:sSup>
-                            </m:e>
-                          </m:d>
-                        </m:e>
-                        <m:sup>
-                          <m:r>
-                            <a:rPr lang="en-US" sz="1400" i="1">
-                              <a:latin typeface="Cambria Math" panose="02040503050406030204" pitchFamily="18" charset="0"/>
-                            </a:rPr>
-                            <m:t>𝑁</m:t>
-                          </m:r>
-                        </m:sup>
-                      </m:sSup>
-                      <m:r>
-                        <a:rPr lang="en-US" sz="1400">
-                          <a:latin typeface="Cambria Math" panose="02040503050406030204" pitchFamily="18" charset="0"/>
-                        </a:rPr>
-                        <m:t>,</m:t>
-                      </m:r>
-                      <m:r>
-                        <a:rPr lang="en-US" sz="1400" smtClean="0">
-                          <a:latin typeface="Cambria Math" panose="02040503050406030204" pitchFamily="18" charset="0"/>
-                        </a:rPr>
-                        <m:t> </m:t>
-                      </m:r>
-                      <m:r>
-                        <a:rPr lang="en-US" sz="1400" b="0" i="1" smtClean="0">
-                          <a:latin typeface="Cambria Math" panose="02040503050406030204" pitchFamily="18" charset="0"/>
-                        </a:rPr>
-                        <m:t> </m:t>
-                      </m:r>
-                      <m:r>
-                        <a:rPr lang="en-US" sz="1400" i="1">
-                          <a:latin typeface="Cambria Math" panose="02040503050406030204" pitchFamily="18" charset="0"/>
-                        </a:rPr>
-                        <m:t>𝜏</m:t>
-                      </m:r>
-                      <m:r>
-                        <a:rPr lang="en-US" sz="1400">
-                          <a:latin typeface="Cambria Math" panose="02040503050406030204" pitchFamily="18" charset="0"/>
-                        </a:rPr>
-                        <m:t>=</m:t>
-                      </m:r>
-                      <m:r>
-                        <a:rPr lang="en-US" sz="1400" i="1">
-                          <a:latin typeface="Cambria Math" panose="02040503050406030204" pitchFamily="18" charset="0"/>
-                        </a:rPr>
-                        <m:t>𝑡</m:t>
-                      </m:r>
-                      <m:r>
-                        <a:rPr lang="en-US" sz="1400">
-                          <a:latin typeface="Cambria Math" panose="02040503050406030204" pitchFamily="18" charset="0"/>
-                        </a:rPr>
-                        <m:t>/</m:t>
-                      </m:r>
-                      <m:r>
-                        <a:rPr lang="en-US" sz="1400" i="1">
-                          <a:latin typeface="Cambria Math" panose="02040503050406030204" pitchFamily="18" charset="0"/>
-                        </a:rPr>
-                        <m:t>𝑁</m:t>
-                      </m:r>
-                    </m:oMath>
-                  </m:oMathPara>
-                </a14:m>
-                <a:endParaRPr lang="en-US" sz="1400" dirty="0"/>
-              </a:p>
-            </p:txBody>
-          </p:sp>
-        </mc:Choice>
-        <mc:Fallback>
-          <p:sp>
-            <p:nvSpPr>
-              <p:cNvPr id="15" name="TextBox 14">
-                <a:extLst>
-                  <a:ext uri="{FF2B5EF4-FFF2-40B4-BE49-F238E27FC236}">
-                    <a16:creationId xmlns:a16="http://schemas.microsoft.com/office/drawing/2014/main" id="{3F81D78E-2635-CA71-64D6-1587924DA2D3}"/>
-                  </a:ext>
-                </a:extLst>
-              </p:cNvPr>
-              <p:cNvSpPr txBox="1">
-                <a:spLocks noRot="1" noChangeAspect="1" noMove="1" noResize="1" noEditPoints="1" noAdjustHandles="1" noChangeArrowheads="1" noChangeShapeType="1" noTextEdit="1"/>
-              </p:cNvSpPr>
-              <p:nvPr/>
-            </p:nvSpPr>
-            <p:spPr>
-              <a:xfrm>
-                <a:off x="5959364" y="5150571"/>
-                <a:ext cx="5592247" cy="1578445"/>
-              </a:xfrm>
-              <a:prstGeom prst="rect">
-                <a:avLst/>
-              </a:prstGeom>
-              <a:blipFill>
-                <a:blip r:embed="rId4"/>
-                <a:stretch>
-                  <a:fillRect l="-654" t="-1158"/>
-                </a:stretch>
-              </a:blipFill>
-            </p:spPr>
-            <p:txBody>
-              <a:bodyPr/>
-              <a:lstStyle/>
-              <a:p>
-                <a:r>
-                  <a:rPr lang="en-US">
-                    <a:noFill/>
-                  </a:rPr>
-                  <a:t> </a:t>
-                </a:r>
-              </a:p>
-            </p:txBody>
-          </p:sp>
-        </mc:Fallback>
-      </mc:AlternateContent>
-      <mc:AlternateContent xmlns:mc="http://schemas.openxmlformats.org/markup-compatibility/2006">
-        <mc:Choice xmlns:a14="http://schemas.microsoft.com/office/drawing/2010/main" Requires="a14">
+      <p:sp>
+        <p:nvSpPr>
+          <p:cNvPr id="15" name="TextBox 14">
+            <a:extLst>
+              <a:ext uri="{FF2B5EF4-FFF2-40B4-BE49-F238E27FC236}">
+                <a16:creationId xmlns:a16="http://schemas.microsoft.com/office/drawing/2014/main" id="{3F81D78E-2635-CA71-64D6-1587924DA2D3}"/>
+              </a:ext>
+            </a:extLst>
+          </p:cNvPr>
+          <p:cNvSpPr txBox="1"/>
+          <p:nvPr/>
+        </p:nvSpPr>
+        <p:spPr>
+          <a:xfrm>
+            <a:off x="5959364" y="5123937"/>
+            <a:ext cx="5592247" cy="1292662"/>
+          </a:xfrm>
+          <a:prstGeom prst="rect">
+            <a:avLst/>
+          </a:prstGeom>
+          <a:noFill/>
+        </p:spPr>
+        <p:txBody>
+          <a:bodyPr wrap="square" rtlCol="0">
+            <a:spAutoFit/>
+          </a:bodyPr>
+          <a:lstStyle/>
+          <a:p>
+            <a:r>
+              <a:rPr lang="en-US" sz="1600" dirty="0"/>
+              <a:t>Determinazione </a:t>
+            </a:r>
+            <a:r>
+              <a:rPr lang="en-US" sz="1600" dirty="0" err="1"/>
+              <a:t>dello</a:t>
+            </a:r>
+            <a:r>
+              <a:rPr lang="en-US" sz="1600" dirty="0"/>
+              <a:t> </a:t>
+            </a:r>
+            <a:r>
+              <a:rPr lang="en-US" sz="1600" b="1" dirty="0" err="1"/>
+              <a:t>stato</a:t>
+            </a:r>
+            <a:r>
+              <a:rPr lang="en-US" sz="1600" b="1" dirty="0"/>
+              <a:t> </a:t>
+            </a:r>
+            <a:r>
+              <a:rPr lang="en-US" sz="1600" b="1" dirty="0" err="1"/>
+              <a:t>fondamentale</a:t>
+            </a:r>
+            <a:r>
+              <a:rPr lang="en-US" sz="1600" dirty="0"/>
+              <a:t> per lo studio </a:t>
+            </a:r>
+            <a:r>
+              <a:rPr lang="en-US" sz="1600" dirty="0" err="1"/>
+              <a:t>statico</a:t>
+            </a:r>
+            <a:r>
+              <a:rPr lang="en-US" sz="1600" dirty="0"/>
+              <a:t> del </a:t>
+            </a:r>
+            <a:r>
+              <a:rPr lang="en-US" sz="1600" dirty="0" err="1"/>
+              <a:t>sistema</a:t>
+            </a:r>
+            <a:r>
+              <a:rPr lang="en-US" sz="1600" dirty="0"/>
+              <a:t>, e </a:t>
+            </a:r>
+            <a:r>
+              <a:rPr lang="en-US" sz="1600" dirty="0" err="1"/>
+              <a:t>simulazione</a:t>
+            </a:r>
+            <a:r>
+              <a:rPr lang="en-US" sz="1600" dirty="0"/>
+              <a:t> delle </a:t>
+            </a:r>
+            <a:r>
+              <a:rPr lang="en-US" sz="1600" dirty="0" err="1"/>
+              <a:t>proprietà</a:t>
+            </a:r>
+            <a:r>
+              <a:rPr lang="en-US" sz="1600" dirty="0"/>
+              <a:t> </a:t>
+            </a:r>
+            <a:r>
+              <a:rPr lang="en-US" sz="1600" dirty="0" err="1"/>
+              <a:t>dinamiche</a:t>
+            </a:r>
+            <a:r>
+              <a:rPr lang="en-US" sz="1600" dirty="0"/>
+              <a:t> come </a:t>
+            </a:r>
+            <a:r>
+              <a:rPr lang="en-US" sz="1600" b="1" dirty="0" err="1"/>
+              <a:t>evoluzione</a:t>
+            </a:r>
+            <a:r>
+              <a:rPr lang="en-US" sz="1600" b="1" dirty="0"/>
+              <a:t> </a:t>
+            </a:r>
+            <a:r>
+              <a:rPr lang="en-US" sz="1600" b="1" dirty="0" err="1"/>
+              <a:t>temporale</a:t>
+            </a:r>
+            <a:r>
+              <a:rPr lang="en-US" sz="1600" b="1" dirty="0"/>
+              <a:t> </a:t>
+            </a:r>
+            <a:r>
+              <a:rPr lang="en-US" sz="1600" dirty="0" err="1"/>
+              <a:t>approssimata</a:t>
+            </a:r>
+            <a:r>
+              <a:rPr lang="en-US" sz="1600" dirty="0"/>
+              <a:t> con la </a:t>
+            </a:r>
+            <a:r>
+              <a:rPr lang="en-US" sz="1600" dirty="0" err="1"/>
+              <a:t>decomposizione</a:t>
+            </a:r>
+            <a:r>
+              <a:rPr lang="en-US" sz="1600" dirty="0"/>
+              <a:t> di </a:t>
+            </a:r>
+            <a:r>
+              <a:rPr lang="en-US" sz="1600" b="1" dirty="0"/>
+              <a:t>Suzuki–Trotter</a:t>
+            </a:r>
+            <a:br>
+              <a:rPr lang="en-US" sz="1400" dirty="0"/>
+            </a:br>
+            <a:endParaRPr lang="en-US" sz="1400" dirty="0"/>
+          </a:p>
+        </p:txBody>
+      </p:sp>
+      <mc:AlternateContent xmlns:mc="http://schemas.openxmlformats.org/markup-compatibility/2006" xmlns:a14="http://schemas.microsoft.com/office/drawing/2010/main">
+        <mc:Choice Requires="a14">
           <p:sp>
             <p:nvSpPr>
               <p:cNvPr id="16" name="TextBox 15">
@@ -3308,7 +2969,7 @@
             </p:txBody>
           </p:sp>
         </mc:Choice>
-        <mc:Fallback>
+        <mc:Fallback xmlns="">
           <p:sp>
             <p:nvSpPr>
               <p:cNvPr id="16" name="TextBox 15">

</xml_diff>